<commit_message>
Now import data in mysql workbench and perform some query like to change table name and others
</commit_message>
<xml_diff>
--- a/Data_Analysis_Project_Report.pptx
+++ b/Data_Analysis_Project_Report.pptx
@@ -5,19 +5,19 @@
     <p:sldMasterId id="2147483648" r:id="rId1"/>
   </p:sldMasterIdLst>
   <p:notesMasterIdLst>
-    <p:notesMasterId r:id="rId4"/>
+    <p:notesMasterId r:id="rId12"/>
   </p:notesMasterIdLst>
   <p:sldIdLst>
-    <p:sldId id="256" r:id="rId3"/>
-    <p:sldId id="258" r:id="rId5"/>
-    <p:sldId id="257" r:id="rId6"/>
-    <p:sldId id="260" r:id="rId7"/>
-    <p:sldId id="261" r:id="rId8"/>
-    <p:sldId id="262" r:id="rId9"/>
-    <p:sldId id="263" r:id="rId10"/>
-    <p:sldId id="264" r:id="rId11"/>
-    <p:sldId id="265" r:id="rId12"/>
-    <p:sldId id="266" r:id="rId13"/>
+    <p:sldId id="256" r:id="rId2"/>
+    <p:sldId id="258" r:id="rId3"/>
+    <p:sldId id="257" r:id="rId4"/>
+    <p:sldId id="260" r:id="rId5"/>
+    <p:sldId id="261" r:id="rId6"/>
+    <p:sldId id="262" r:id="rId7"/>
+    <p:sldId id="263" r:id="rId8"/>
+    <p:sldId id="264" r:id="rId9"/>
+    <p:sldId id="265" r:id="rId10"/>
+    <p:sldId id="266" r:id="rId11"/>
   </p:sldIdLst>
   <p:sldSz cx="9144000" cy="5143500" type="screen16x9"/>
   <p:notesSz cx="5143500" cy="9144000"/>
@@ -139,6 +139,9 @@
           </p14:sldIdLst>
         </p14:section>
       </p14:sectionLst>
+    </p:ext>
+    <p:ext uri="{EFAFB233-063F-42B5-8137-9DF3F51BA10A}">
+      <p15:sldGuideLst xmlns:p15="http://schemas.microsoft.com/office/powerpoint/2012/main"/>
     </p:ext>
   </p:extLst>
 </p:presentation>
@@ -292,6 +295,13 @@
           </p:nvPr>
         </p:nvSpPr>
         <p:spPr/>
+        <p:txBody>
+          <a:bodyPr/>
+          <a:lstStyle/>
+          <a:p>
+            <a:endParaRPr lang="en-IN"/>
+          </a:p>
+        </p:txBody>
       </p:sp>
       <p:sp>
         <p:nvSpPr>
@@ -329,6 +339,7 @@
           <a:p>
             <a:fld id="{F7021451-1387-4CA6-816F-3879F97B5CBC}" type="slidenum">
               <a:rPr lang="en-US"/>
+              <a:t>1</a:t>
             </a:fld>
             <a:endParaRPr lang="en-US"/>
           </a:p>
@@ -370,6 +381,13 @@
           </p:nvPr>
         </p:nvSpPr>
         <p:spPr/>
+        <p:txBody>
+          <a:bodyPr/>
+          <a:lstStyle/>
+          <a:p>
+            <a:endParaRPr lang="en-IN"/>
+          </a:p>
+        </p:txBody>
       </p:sp>
       <p:sp>
         <p:nvSpPr>
@@ -407,6 +425,7 @@
           <a:p>
             <a:fld id="{F7021451-1387-4CA6-816F-3879F97B5CBC}" type="slidenum">
               <a:rPr lang="en-US"/>
+              <a:t>10</a:t>
             </a:fld>
             <a:endParaRPr lang="en-US"/>
           </a:p>
@@ -448,6 +467,13 @@
           </p:nvPr>
         </p:nvSpPr>
         <p:spPr/>
+        <p:txBody>
+          <a:bodyPr/>
+          <a:lstStyle/>
+          <a:p>
+            <a:endParaRPr lang="en-IN"/>
+          </a:p>
+        </p:txBody>
       </p:sp>
       <p:sp>
         <p:nvSpPr>
@@ -485,6 +511,7 @@
           <a:p>
             <a:fld id="{F7021451-1387-4CA6-816F-3879F97B5CBC}" type="slidenum">
               <a:rPr lang="en-US"/>
+              <a:t>2</a:t>
             </a:fld>
             <a:endParaRPr lang="en-US"/>
           </a:p>
@@ -526,6 +553,13 @@
           </p:nvPr>
         </p:nvSpPr>
         <p:spPr/>
+        <p:txBody>
+          <a:bodyPr/>
+          <a:lstStyle/>
+          <a:p>
+            <a:endParaRPr lang="en-IN"/>
+          </a:p>
+        </p:txBody>
       </p:sp>
       <p:sp>
         <p:nvSpPr>
@@ -563,6 +597,7 @@
           <a:p>
             <a:fld id="{F7021451-1387-4CA6-816F-3879F97B5CBC}" type="slidenum">
               <a:rPr lang="en-US"/>
+              <a:t>3</a:t>
             </a:fld>
             <a:endParaRPr lang="en-US"/>
           </a:p>
@@ -604,6 +639,13 @@
           </p:nvPr>
         </p:nvSpPr>
         <p:spPr/>
+        <p:txBody>
+          <a:bodyPr/>
+          <a:lstStyle/>
+          <a:p>
+            <a:endParaRPr lang="en-IN"/>
+          </a:p>
+        </p:txBody>
       </p:sp>
       <p:sp>
         <p:nvSpPr>
@@ -641,6 +683,7 @@
           <a:p>
             <a:fld id="{F7021451-1387-4CA6-816F-3879F97B5CBC}" type="slidenum">
               <a:rPr lang="en-US"/>
+              <a:t>4</a:t>
             </a:fld>
             <a:endParaRPr lang="en-US"/>
           </a:p>
@@ -682,6 +725,13 @@
           </p:nvPr>
         </p:nvSpPr>
         <p:spPr/>
+        <p:txBody>
+          <a:bodyPr/>
+          <a:lstStyle/>
+          <a:p>
+            <a:endParaRPr lang="en-IN"/>
+          </a:p>
+        </p:txBody>
       </p:sp>
       <p:sp>
         <p:nvSpPr>
@@ -719,6 +769,7 @@
           <a:p>
             <a:fld id="{F7021451-1387-4CA6-816F-3879F97B5CBC}" type="slidenum">
               <a:rPr lang="en-US"/>
+              <a:t>5</a:t>
             </a:fld>
             <a:endParaRPr lang="en-US"/>
           </a:p>
@@ -760,6 +811,13 @@
           </p:nvPr>
         </p:nvSpPr>
         <p:spPr/>
+        <p:txBody>
+          <a:bodyPr/>
+          <a:lstStyle/>
+          <a:p>
+            <a:endParaRPr lang="en-IN"/>
+          </a:p>
+        </p:txBody>
       </p:sp>
       <p:sp>
         <p:nvSpPr>
@@ -797,6 +855,7 @@
           <a:p>
             <a:fld id="{F7021451-1387-4CA6-816F-3879F97B5CBC}" type="slidenum">
               <a:rPr lang="en-US"/>
+              <a:t>6</a:t>
             </a:fld>
             <a:endParaRPr lang="en-US"/>
           </a:p>
@@ -838,6 +897,13 @@
           </p:nvPr>
         </p:nvSpPr>
         <p:spPr/>
+        <p:txBody>
+          <a:bodyPr/>
+          <a:lstStyle/>
+          <a:p>
+            <a:endParaRPr lang="en-IN"/>
+          </a:p>
+        </p:txBody>
       </p:sp>
       <p:sp>
         <p:nvSpPr>
@@ -875,6 +941,7 @@
           <a:p>
             <a:fld id="{F7021451-1387-4CA6-816F-3879F97B5CBC}" type="slidenum">
               <a:rPr lang="en-US"/>
+              <a:t>7</a:t>
             </a:fld>
             <a:endParaRPr lang="en-US"/>
           </a:p>
@@ -916,6 +983,13 @@
           </p:nvPr>
         </p:nvSpPr>
         <p:spPr/>
+        <p:txBody>
+          <a:bodyPr/>
+          <a:lstStyle/>
+          <a:p>
+            <a:endParaRPr lang="en-IN"/>
+          </a:p>
+        </p:txBody>
       </p:sp>
       <p:sp>
         <p:nvSpPr>
@@ -953,6 +1027,7 @@
           <a:p>
             <a:fld id="{F7021451-1387-4CA6-816F-3879F97B5CBC}" type="slidenum">
               <a:rPr lang="en-US"/>
+              <a:t>8</a:t>
             </a:fld>
             <a:endParaRPr lang="en-US"/>
           </a:p>
@@ -994,6 +1069,13 @@
           </p:nvPr>
         </p:nvSpPr>
         <p:spPr/>
+        <p:txBody>
+          <a:bodyPr/>
+          <a:lstStyle/>
+          <a:p>
+            <a:endParaRPr lang="en-IN"/>
+          </a:p>
+        </p:txBody>
       </p:sp>
       <p:sp>
         <p:nvSpPr>
@@ -1031,6 +1113,7 @@
           <a:p>
             <a:fld id="{F7021451-1387-4CA6-816F-3879F97B5CBC}" type="slidenum">
               <a:rPr lang="en-US"/>
+              <a:t>9</a:t>
             </a:fld>
             <a:endParaRPr lang="en-US"/>
           </a:p>
@@ -1217,6 +1300,7 @@
             <a:pPr algn="l"/>
             <a:fld id="{F7021451-1387-4CA6-816F-3879F97B5CBC}" type="slidenum">
               <a:rPr lang="en-US" b="0"/>
+              <a:t>‹#›</a:t>
             </a:fld>
             <a:endParaRPr lang="en-US"/>
           </a:p>
@@ -1373,6 +1457,7 @@
             <a:pPr algn="l"/>
             <a:fld id="{F7021451-1387-4CA6-816F-3879F97B5CBC}" type="slidenum">
               <a:rPr lang="en-US" b="0"/>
+              <a:t>‹#›</a:t>
             </a:fld>
             <a:endParaRPr lang="en-US"/>
           </a:p>
@@ -1442,6 +1527,7 @@
             <a:pPr algn="l"/>
             <a:fld id="{F7021451-1387-4CA6-816F-3879F97B5CBC}" type="slidenum">
               <a:rPr lang="en-US" b="0"/>
+              <a:t>‹#›</a:t>
             </a:fld>
             <a:endParaRPr lang="en-US"/>
           </a:p>
@@ -1738,7 +1824,7 @@
         </p:nvSpPr>
         <p:spPr>
           <a:xfrm>
-            <a:off x="548640" y="502920"/>
+            <a:off x="548640" y="731520"/>
             <a:ext cx="8046720" cy="1097280"/>
           </a:xfrm>
           <a:prstGeom prst="rect">
@@ -1776,7 +1862,7 @@
         </p:nvSpPr>
         <p:spPr>
           <a:xfrm>
-            <a:off x="548640" y="1645920"/>
+            <a:off x="640080" y="1691640"/>
             <a:ext cx="8046720" cy="411480"/>
           </a:xfrm>
           <a:prstGeom prst="rect">
@@ -1836,6 +1922,13 @@
             <a:prstDash val="solid"/>
           </a:ln>
         </p:spPr>
+        <p:txBody>
+          <a:bodyPr/>
+          <a:lstStyle/>
+          <a:p>
+            <a:endParaRPr lang="en-IN"/>
+          </a:p>
+        </p:txBody>
       </p:sp>
       <p:sp>
         <p:nvSpPr>
@@ -1855,6 +1948,13 @@
             <a:schemeClr val="accent2"/>
           </a:solidFill>
         </p:spPr>
+        <p:txBody>
+          <a:bodyPr/>
+          <a:lstStyle/>
+          <a:p>
+            <a:endParaRPr lang="en-IN"/>
+          </a:p>
+        </p:txBody>
       </p:sp>
       <p:sp>
         <p:nvSpPr>
@@ -1962,6 +2062,13 @@
             <a:prstDash val="solid"/>
           </a:ln>
         </p:spPr>
+        <p:txBody>
+          <a:bodyPr/>
+          <a:lstStyle/>
+          <a:p>
+            <a:endParaRPr lang="en-IN"/>
+          </a:p>
+        </p:txBody>
       </p:sp>
       <p:sp>
         <p:nvSpPr>
@@ -1981,6 +2088,13 @@
             <a:schemeClr val="accent2"/>
           </a:solidFill>
         </p:spPr>
+        <p:txBody>
+          <a:bodyPr/>
+          <a:lstStyle/>
+          <a:p>
+            <a:endParaRPr lang="en-IN"/>
+          </a:p>
+        </p:txBody>
       </p:sp>
       <p:sp>
         <p:nvSpPr>
@@ -2088,6 +2202,13 @@
             <a:prstDash val="solid"/>
           </a:ln>
         </p:spPr>
+        <p:txBody>
+          <a:bodyPr/>
+          <a:lstStyle/>
+          <a:p>
+            <a:endParaRPr lang="en-IN"/>
+          </a:p>
+        </p:txBody>
       </p:sp>
       <p:sp>
         <p:nvSpPr>
@@ -2107,6 +2228,13 @@
             <a:schemeClr val="accent2"/>
           </a:solidFill>
         </p:spPr>
+        <p:txBody>
+          <a:bodyPr/>
+          <a:lstStyle/>
+          <a:p>
+            <a:endParaRPr lang="en-IN"/>
+          </a:p>
+        </p:txBody>
       </p:sp>
       <p:sp>
         <p:nvSpPr>
@@ -2214,6 +2342,13 @@
             <a:prstDash val="solid"/>
           </a:ln>
         </p:spPr>
+        <p:txBody>
+          <a:bodyPr/>
+          <a:lstStyle/>
+          <a:p>
+            <a:endParaRPr lang="en-IN"/>
+          </a:p>
+        </p:txBody>
       </p:sp>
       <p:sp>
         <p:nvSpPr>
@@ -2233,6 +2368,13 @@
             <a:schemeClr val="accent2"/>
           </a:solidFill>
         </p:spPr>
+        <p:txBody>
+          <a:bodyPr/>
+          <a:lstStyle/>
+          <a:p>
+            <a:endParaRPr lang="en-IN"/>
+          </a:p>
+        </p:txBody>
       </p:sp>
       <p:sp>
         <p:nvSpPr>
@@ -2344,8 +2486,52 @@
             <a:pPr algn="l"/>
             <a:fld id="{F7021451-1387-4CA6-816F-3879F97B5CBC}" type="slidenum">
               <a:rPr lang="en-US" b="0"/>
+              <a:t>1</a:t>
             </a:fld>
             <a:endParaRPr lang="en-US"/>
+          </a:p>
+        </p:txBody>
+      </p:sp>
+      <p:sp>
+        <p:nvSpPr>
+          <p:cNvPr id="22" name="g1_sub">
+            <a:extLst>
+              <a:ext uri="{FF2B5EF4-FFF2-40B4-BE49-F238E27FC236}">
+                <a16:creationId xmlns:a16="http://schemas.microsoft.com/office/drawing/2014/main" id="{503AD420-AEB5-6CB8-DA57-56287DBDE697}"/>
+              </a:ext>
+            </a:extLst>
+          </p:cNvPr>
+          <p:cNvSpPr txBox="1"/>
+          <p:nvPr/>
+        </p:nvSpPr>
+        <p:spPr>
+          <a:xfrm>
+            <a:off x="640080" y="316523"/>
+            <a:ext cx="8046720" cy="411480"/>
+          </a:xfrm>
+          <a:prstGeom prst="rect">
+            <a:avLst/>
+          </a:prstGeom>
+          <a:noFill/>
+        </p:spPr>
+        <p:txBody>
+          <a:bodyPr wrap="square" lIns="0" tIns="0" rIns="0" bIns="0" rtlCol="0" anchor="ctr"/>
+          <a:lstStyle/>
+          <a:p>
+            <a:pPr marL="0" indent="0">
+              <a:buNone/>
+            </a:pPr>
+            <a:r>
+              <a:rPr lang="en-US" sz="2000" dirty="0">
+                <a:solidFill>
+                  <a:schemeClr val="accent2"/>
+                </a:solidFill>
+                <a:latin typeface="Cambria" panose="02040503050406030204" pitchFamily="34" charset="0"/>
+                <a:ea typeface="Cambria" panose="02040503050406030204" pitchFamily="34" charset="-122"/>
+              </a:rPr>
+              <a:t>Name : Fahim Shahenshah Yadgir</a:t>
+            </a:r>
+            <a:endParaRPr lang="en-US" sz="2000" dirty="0"/>
           </a:p>
         </p:txBody>
       </p:sp>
@@ -3038,6 +3224,59 @@
                                         <p:cTn id="63" dur="500"/>
                                         <p:tgtEl>
                                           <p:spTgt spid="19"/>
+                                        </p:tgtEl>
+                                      </p:cBhvr>
+                                    </p:animEffect>
+                                  </p:childTnLst>
+                                </p:cTn>
+                              </p:par>
+                            </p:childTnLst>
+                          </p:cTn>
+                        </p:par>
+                      </p:childTnLst>
+                    </p:cTn>
+                  </p:par>
+                  <p:par>
+                    <p:cTn id="64" fill="hold">
+                      <p:stCondLst>
+                        <p:cond delay="indefinite"/>
+                      </p:stCondLst>
+                      <p:childTnLst>
+                        <p:par>
+                          <p:cTn id="65" fill="hold">
+                            <p:stCondLst>
+                              <p:cond delay="0"/>
+                            </p:stCondLst>
+                            <p:childTnLst>
+                              <p:par>
+                                <p:cTn id="66" presetID="10" presetClass="entr" presetSubtype="0" fill="hold" nodeType="clickEffect">
+                                  <p:stCondLst>
+                                    <p:cond delay="0"/>
+                                  </p:stCondLst>
+                                  <p:childTnLst>
+                                    <p:set>
+                                      <p:cBhvr>
+                                        <p:cTn id="67" dur="1" fill="hold">
+                                          <p:stCondLst>
+                                            <p:cond delay="0"/>
+                                          </p:stCondLst>
+                                        </p:cTn>
+                                        <p:tgtEl>
+                                          <p:spTgt spid="22"/>
+                                        </p:tgtEl>
+                                        <p:attrNameLst>
+                                          <p:attrName>style.visibility</p:attrName>
+                                        </p:attrNameLst>
+                                      </p:cBhvr>
+                                      <p:to>
+                                        <p:strVal val="visible"/>
+                                      </p:to>
+                                    </p:set>
+                                    <p:animEffect transition="in" filter="fade">
+                                      <p:cBhvr>
+                                        <p:cTn id="68" dur="500"/>
+                                        <p:tgtEl>
+                                          <p:spTgt spid="22"/>
                                         </p:tgtEl>
                                       </p:cBhvr>
                                     </p:animEffect>
@@ -3164,6 +3403,13 @@
             <a:prstDash val="solid"/>
           </a:ln>
         </p:spPr>
+        <p:txBody>
+          <a:bodyPr/>
+          <a:lstStyle/>
+          <a:p>
+            <a:endParaRPr lang="en-IN"/>
+          </a:p>
+        </p:txBody>
       </p:sp>
       <p:sp>
         <p:nvSpPr>
@@ -3271,6 +3517,13 @@
             <a:prstDash val="solid"/>
           </a:ln>
         </p:spPr>
+        <p:txBody>
+          <a:bodyPr/>
+          <a:lstStyle/>
+          <a:p>
+            <a:endParaRPr lang="en-IN"/>
+          </a:p>
+        </p:txBody>
       </p:sp>
       <p:sp>
         <p:nvSpPr>
@@ -3378,6 +3631,13 @@
             <a:prstDash val="solid"/>
           </a:ln>
         </p:spPr>
+        <p:txBody>
+          <a:bodyPr/>
+          <a:lstStyle/>
+          <a:p>
+            <a:endParaRPr lang="en-IN"/>
+          </a:p>
+        </p:txBody>
       </p:sp>
       <p:sp>
         <p:nvSpPr>
@@ -3485,6 +3745,13 @@
             <a:prstDash val="solid"/>
           </a:ln>
         </p:spPr>
+        <p:txBody>
+          <a:bodyPr/>
+          <a:lstStyle/>
+          <a:p>
+            <a:endParaRPr lang="en-IN"/>
+          </a:p>
+        </p:txBody>
       </p:sp>
       <p:sp>
         <p:nvSpPr>
@@ -3596,6 +3863,7 @@
             <a:pPr algn="l"/>
             <a:fld id="{F7021451-1387-4CA6-816F-3879F97B5CBC}" type="slidenum">
               <a:rPr lang="en-US" b="0"/>
+              <a:t>10</a:t>
             </a:fld>
             <a:endParaRPr lang="en-US"/>
           </a:p>
@@ -4226,6 +4494,13 @@
             </a:outerShdw>
           </a:effectLst>
         </p:spPr>
+        <p:txBody>
+          <a:bodyPr/>
+          <a:lstStyle/>
+          <a:p>
+            <a:endParaRPr lang="en-IN"/>
+          </a:p>
+        </p:txBody>
       </p:sp>
       <p:pic>
         <p:nvPicPr>
@@ -4236,7 +4511,7 @@
           <p:nvPr/>
         </p:nvPicPr>
         <p:blipFill>
-          <a:blip r:embed="rId1"/>
+          <a:blip r:embed="rId3"/>
           <a:stretch>
             <a:fillRect/>
           </a:stretch>
@@ -4284,6 +4559,13 @@
             </a:outerShdw>
           </a:effectLst>
         </p:spPr>
+        <p:txBody>
+          <a:bodyPr/>
+          <a:lstStyle/>
+          <a:p>
+            <a:endParaRPr lang="en-IN"/>
+          </a:p>
+        </p:txBody>
       </p:sp>
       <p:sp>
         <p:nvSpPr>
@@ -4432,6 +4714,13 @@
             </a:outerShdw>
           </a:effectLst>
         </p:spPr>
+        <p:txBody>
+          <a:bodyPr/>
+          <a:lstStyle/>
+          <a:p>
+            <a:endParaRPr lang="en-IN"/>
+          </a:p>
+        </p:txBody>
       </p:sp>
       <p:sp>
         <p:nvSpPr>
@@ -4581,6 +4870,7 @@
             <a:pPr algn="l"/>
             <a:fld id="{F7021451-1387-4CA6-816F-3879F97B5CBC}" type="slidenum">
               <a:rPr lang="en-US" b="0"/>
+              <a:t>2</a:t>
             </a:fld>
             <a:endParaRPr lang="en-US"/>
           </a:p>
@@ -5123,6 +5413,13 @@
             </a:outerShdw>
           </a:effectLst>
         </p:spPr>
+        <p:txBody>
+          <a:bodyPr/>
+          <a:lstStyle/>
+          <a:p>
+            <a:endParaRPr lang="en-IN"/>
+          </a:p>
+        </p:txBody>
       </p:sp>
       <p:sp>
         <p:nvSpPr>
@@ -5378,6 +5675,13 @@
             <a:prstDash val="solid"/>
           </a:ln>
         </p:spPr>
+        <p:txBody>
+          <a:bodyPr/>
+          <a:lstStyle/>
+          <a:p>
+            <a:endParaRPr lang="en-IN"/>
+          </a:p>
+        </p:txBody>
       </p:sp>
       <p:sp>
         <p:nvSpPr>
@@ -5461,6 +5765,13 @@
             </a:outerShdw>
           </a:effectLst>
         </p:spPr>
+        <p:txBody>
+          <a:bodyPr/>
+          <a:lstStyle/>
+          <a:p>
+            <a:endParaRPr lang="en-IN"/>
+          </a:p>
+        </p:txBody>
       </p:sp>
       <p:sp>
         <p:nvSpPr>
@@ -5716,6 +6027,13 @@
             <a:prstDash val="solid"/>
           </a:ln>
         </p:spPr>
+        <p:txBody>
+          <a:bodyPr/>
+          <a:lstStyle/>
+          <a:p>
+            <a:endParaRPr lang="en-IN"/>
+          </a:p>
+        </p:txBody>
       </p:sp>
       <p:sp>
         <p:nvSpPr>
@@ -5799,6 +6117,13 @@
             </a:outerShdw>
           </a:effectLst>
         </p:spPr>
+        <p:txBody>
+          <a:bodyPr/>
+          <a:lstStyle/>
+          <a:p>
+            <a:endParaRPr lang="en-IN"/>
+          </a:p>
+        </p:txBody>
       </p:sp>
       <p:sp>
         <p:nvSpPr>
@@ -6054,6 +6379,13 @@
             <a:prstDash val="solid"/>
           </a:ln>
         </p:spPr>
+        <p:txBody>
+          <a:bodyPr/>
+          <a:lstStyle/>
+          <a:p>
+            <a:endParaRPr lang="en-IN"/>
+          </a:p>
+        </p:txBody>
       </p:sp>
       <p:sp>
         <p:nvSpPr>
@@ -6138,6 +6470,7 @@
             <a:pPr algn="l"/>
             <a:fld id="{F7021451-1387-4CA6-816F-3879F97B5CBC}" type="slidenum">
               <a:rPr lang="en-US" b="0"/>
+              <a:t>3</a:t>
             </a:fld>
             <a:endParaRPr lang="en-US"/>
           </a:p>
@@ -7275,6 +7608,13 @@
             </a:outerShdw>
           </a:effectLst>
         </p:spPr>
+        <p:txBody>
+          <a:bodyPr/>
+          <a:lstStyle/>
+          <a:p>
+            <a:endParaRPr lang="en-IN"/>
+          </a:p>
+        </p:txBody>
       </p:sp>
       <p:pic>
         <p:nvPicPr>
@@ -7285,7 +7625,7 @@
           <p:nvPr/>
         </p:nvPicPr>
         <p:blipFill>
-          <a:blip r:embed="rId1"/>
+          <a:blip r:embed="rId3"/>
           <a:stretch>
             <a:fillRect/>
           </a:stretch>
@@ -7333,6 +7673,13 @@
             </a:outerShdw>
           </a:effectLst>
         </p:spPr>
+        <p:txBody>
+          <a:bodyPr/>
+          <a:lstStyle/>
+          <a:p>
+            <a:endParaRPr lang="en-IN"/>
+          </a:p>
+        </p:txBody>
       </p:sp>
       <p:sp>
         <p:nvSpPr>
@@ -7481,6 +7828,13 @@
             </a:outerShdw>
           </a:effectLst>
         </p:spPr>
+        <p:txBody>
+          <a:bodyPr/>
+          <a:lstStyle/>
+          <a:p>
+            <a:endParaRPr lang="en-IN"/>
+          </a:p>
+        </p:txBody>
       </p:sp>
       <p:sp>
         <p:nvSpPr>
@@ -7630,6 +7984,7 @@
             <a:pPr algn="l"/>
             <a:fld id="{F7021451-1387-4CA6-816F-3879F97B5CBC}" type="slidenum">
               <a:rPr lang="en-US" b="0"/>
+              <a:t>4</a:t>
             </a:fld>
             <a:endParaRPr lang="en-US"/>
           </a:p>
@@ -8156,9 +8511,27 @@
             <a:tbl>
               <a:tblPr/>
               <a:tblGrid>
-                <a:gridCol w="3200400"/>
-                <a:gridCol w="2560320"/>
-                <a:gridCol w="2468880"/>
+                <a:gridCol w="3200400">
+                  <a:extLst>
+                    <a:ext uri="{9D8B030D-6E8A-4147-A177-3AD203B41FA5}">
+                      <a16:colId xmlns:a16="http://schemas.microsoft.com/office/drawing/2014/main" val="20000"/>
+                    </a:ext>
+                  </a:extLst>
+                </a:gridCol>
+                <a:gridCol w="2560320">
+                  <a:extLst>
+                    <a:ext uri="{9D8B030D-6E8A-4147-A177-3AD203B41FA5}">
+                      <a16:colId xmlns:a16="http://schemas.microsoft.com/office/drawing/2014/main" val="20001"/>
+                    </a:ext>
+                  </a:extLst>
+                </a:gridCol>
+                <a:gridCol w="2468880">
+                  <a:extLst>
+                    <a:ext uri="{9D8B030D-6E8A-4147-A177-3AD203B41FA5}">
+                      <a16:colId xmlns:a16="http://schemas.microsoft.com/office/drawing/2014/main" val="20002"/>
+                    </a:ext>
+                  </a:extLst>
+                </a:gridCol>
               </a:tblGrid>
               <a:tr h="365760">
                 <a:tc>
@@ -8365,6 +8738,11 @@
                     </a:solidFill>
                   </a:tcPr>
                 </a:tc>
+                <a:extLst>
+                  <a:ext uri="{0D108BD9-81ED-4DB2-BD59-A6C34878D82A}">
+                    <a16:rowId xmlns:a16="http://schemas.microsoft.com/office/drawing/2014/main" val="10000"/>
+                  </a:ext>
+                </a:extLst>
               </a:tr>
               <a:tr h="365760">
                 <a:tc>
@@ -8571,6 +8949,11 @@
                     </a:solidFill>
                   </a:tcPr>
                 </a:tc>
+                <a:extLst>
+                  <a:ext uri="{0D108BD9-81ED-4DB2-BD59-A6C34878D82A}">
+                    <a16:rowId xmlns:a16="http://schemas.microsoft.com/office/drawing/2014/main" val="10001"/>
+                  </a:ext>
+                </a:extLst>
               </a:tr>
               <a:tr h="365760">
                 <a:tc>
@@ -8777,6 +9160,11 @@
                     </a:solidFill>
                   </a:tcPr>
                 </a:tc>
+                <a:extLst>
+                  <a:ext uri="{0D108BD9-81ED-4DB2-BD59-A6C34878D82A}">
+                    <a16:rowId xmlns:a16="http://schemas.microsoft.com/office/drawing/2014/main" val="10002"/>
+                  </a:ext>
+                </a:extLst>
               </a:tr>
               <a:tr h="365760">
                 <a:tc>
@@ -8983,6 +9371,11 @@
                     </a:solidFill>
                   </a:tcPr>
                 </a:tc>
+                <a:extLst>
+                  <a:ext uri="{0D108BD9-81ED-4DB2-BD59-A6C34878D82A}">
+                    <a16:rowId xmlns:a16="http://schemas.microsoft.com/office/drawing/2014/main" val="10003"/>
+                  </a:ext>
+                </a:extLst>
               </a:tr>
               <a:tr h="365760">
                 <a:tc>
@@ -9189,6 +9582,11 @@
                     </a:solidFill>
                   </a:tcPr>
                 </a:tc>
+                <a:extLst>
+                  <a:ext uri="{0D108BD9-81ED-4DB2-BD59-A6C34878D82A}">
+                    <a16:rowId xmlns:a16="http://schemas.microsoft.com/office/drawing/2014/main" val="10004"/>
+                  </a:ext>
+                </a:extLst>
               </a:tr>
             </a:tbl>
           </a:graphicData>
@@ -9227,6 +9625,13 @@
             </a:outerShdw>
           </a:effectLst>
         </p:spPr>
+        <p:txBody>
+          <a:bodyPr/>
+          <a:lstStyle/>
+          <a:p>
+            <a:endParaRPr lang="en-IN"/>
+          </a:p>
+        </p:txBody>
       </p:sp>
       <p:sp>
         <p:nvSpPr>
@@ -9337,6 +9742,13 @@
             </a:outerShdw>
           </a:effectLst>
         </p:spPr>
+        <p:txBody>
+          <a:bodyPr/>
+          <a:lstStyle/>
+          <a:p>
+            <a:endParaRPr lang="en-IN"/>
+          </a:p>
+        </p:txBody>
       </p:sp>
       <p:sp>
         <p:nvSpPr>
@@ -9447,6 +9859,13 @@
             </a:outerShdw>
           </a:effectLst>
         </p:spPr>
+        <p:txBody>
+          <a:bodyPr/>
+          <a:lstStyle/>
+          <a:p>
+            <a:endParaRPr lang="en-IN"/>
+          </a:p>
+        </p:txBody>
       </p:sp>
       <p:sp>
         <p:nvSpPr>
@@ -9558,6 +9977,7 @@
             <a:pPr algn="l"/>
             <a:fld id="{F7021451-1387-4CA6-816F-3879F97B5CBC}" type="slidenum">
               <a:rPr lang="en-US" b="0"/>
+              <a:t>5</a:t>
             </a:fld>
             <a:endParaRPr lang="en-US"/>
           </a:p>
@@ -10118,6 +10538,13 @@
             </a:outerShdw>
           </a:effectLst>
         </p:spPr>
+        <p:txBody>
+          <a:bodyPr/>
+          <a:lstStyle/>
+          <a:p>
+            <a:endParaRPr lang="en-IN"/>
+          </a:p>
+        </p:txBody>
       </p:sp>
       <p:pic>
         <p:nvPicPr>
@@ -10128,7 +10555,7 @@
           <p:nvPr/>
         </p:nvPicPr>
         <p:blipFill>
-          <a:blip r:embed="rId1"/>
+          <a:blip r:embed="rId3"/>
           <a:stretch>
             <a:fillRect/>
           </a:stretch>
@@ -10176,6 +10603,13 @@
             </a:outerShdw>
           </a:effectLst>
         </p:spPr>
+        <p:txBody>
+          <a:bodyPr/>
+          <a:lstStyle/>
+          <a:p>
+            <a:endParaRPr lang="en-IN"/>
+          </a:p>
+        </p:txBody>
       </p:sp>
       <p:sp>
         <p:nvSpPr>
@@ -10286,6 +10720,13 @@
             </a:outerShdw>
           </a:effectLst>
         </p:spPr>
+        <p:txBody>
+          <a:bodyPr/>
+          <a:lstStyle/>
+          <a:p>
+            <a:endParaRPr lang="en-IN"/>
+          </a:p>
+        </p:txBody>
       </p:sp>
       <p:sp>
         <p:nvSpPr>
@@ -10369,6 +10810,13 @@
             </a:outerShdw>
           </a:effectLst>
         </p:spPr>
+        <p:txBody>
+          <a:bodyPr/>
+          <a:lstStyle/>
+          <a:p>
+            <a:endParaRPr lang="en-IN"/>
+          </a:p>
+        </p:txBody>
       </p:sp>
       <p:sp>
         <p:nvSpPr>
@@ -10445,6 +10893,13 @@
             <a:prstDash val="solid"/>
           </a:ln>
         </p:spPr>
+        <p:txBody>
+          <a:bodyPr/>
+          <a:lstStyle/>
+          <a:p>
+            <a:endParaRPr lang="en-IN"/>
+          </a:p>
+        </p:txBody>
       </p:sp>
       <p:sp>
         <p:nvSpPr>
@@ -10529,6 +10984,7 @@
             <a:pPr algn="l"/>
             <a:fld id="{F7021451-1387-4CA6-816F-3879F97B5CBC}" type="slidenum">
               <a:rPr lang="en-US" b="0"/>
+              <a:t>6</a:t>
             </a:fld>
             <a:endParaRPr lang="en-US"/>
           </a:p>
@@ -11142,6 +11598,13 @@
             </a:outerShdw>
           </a:effectLst>
         </p:spPr>
+        <p:txBody>
+          <a:bodyPr/>
+          <a:lstStyle/>
+          <a:p>
+            <a:endParaRPr lang="en-IN"/>
+          </a:p>
+        </p:txBody>
       </p:sp>
       <p:sp>
         <p:nvSpPr>
@@ -11252,6 +11715,13 @@
             </a:outerShdw>
           </a:effectLst>
         </p:spPr>
+        <p:txBody>
+          <a:bodyPr/>
+          <a:lstStyle/>
+          <a:p>
+            <a:endParaRPr lang="en-IN"/>
+          </a:p>
+        </p:txBody>
       </p:sp>
       <p:sp>
         <p:nvSpPr>
@@ -11362,6 +11832,13 @@
             </a:outerShdw>
           </a:effectLst>
         </p:spPr>
+        <p:txBody>
+          <a:bodyPr/>
+          <a:lstStyle/>
+          <a:p>
+            <a:endParaRPr lang="en-IN"/>
+          </a:p>
+        </p:txBody>
       </p:sp>
       <p:sp>
         <p:nvSpPr>
@@ -11472,6 +11949,13 @@
             </a:outerShdw>
           </a:effectLst>
         </p:spPr>
+        <p:txBody>
+          <a:bodyPr/>
+          <a:lstStyle/>
+          <a:p>
+            <a:endParaRPr lang="en-IN"/>
+          </a:p>
+        </p:txBody>
       </p:sp>
       <p:sp>
         <p:nvSpPr>
@@ -11520,7 +12004,7 @@
           <p:nvPr/>
         </p:nvPicPr>
         <p:blipFill>
-          <a:blip r:embed="rId1"/>
+          <a:blip r:embed="rId3"/>
           <a:stretch>
             <a:fillRect/>
           </a:stretch>
@@ -11828,6 +12312,7 @@
             <a:pPr algn="l"/>
             <a:fld id="{F7021451-1387-4CA6-816F-3879F97B5CBC}" type="slidenum">
               <a:rPr lang="en-US" b="0"/>
+              <a:t>7</a:t>
             </a:fld>
             <a:endParaRPr lang="en-US"/>
           </a:p>
@@ -12598,6 +13083,13 @@
             </a:outerShdw>
           </a:effectLst>
         </p:spPr>
+        <p:txBody>
+          <a:bodyPr/>
+          <a:lstStyle/>
+          <a:p>
+            <a:endParaRPr lang="en-IN"/>
+          </a:p>
+        </p:txBody>
       </p:sp>
       <p:pic>
         <p:nvPicPr>
@@ -12608,7 +13100,7 @@
           <p:nvPr/>
         </p:nvPicPr>
         <p:blipFill>
-          <a:blip r:embed="rId1"/>
+          <a:blip r:embed="rId3"/>
           <a:stretch>
             <a:fillRect/>
           </a:stretch>
@@ -12656,6 +13148,13 @@
             </a:outerShdw>
           </a:effectLst>
         </p:spPr>
+        <p:txBody>
+          <a:bodyPr/>
+          <a:lstStyle/>
+          <a:p>
+            <a:endParaRPr lang="en-IN"/>
+          </a:p>
+        </p:txBody>
       </p:sp>
       <p:sp>
         <p:nvSpPr>
@@ -12739,6 +13238,13 @@
             </a:outerShdw>
           </a:effectLst>
         </p:spPr>
+        <p:txBody>
+          <a:bodyPr/>
+          <a:lstStyle/>
+          <a:p>
+            <a:endParaRPr lang="en-IN"/>
+          </a:p>
+        </p:txBody>
       </p:sp>
       <p:sp>
         <p:nvSpPr>
@@ -12822,6 +13328,13 @@
             </a:outerShdw>
           </a:effectLst>
         </p:spPr>
+        <p:txBody>
+          <a:bodyPr/>
+          <a:lstStyle/>
+          <a:p>
+            <a:endParaRPr lang="en-IN"/>
+          </a:p>
+        </p:txBody>
       </p:sp>
       <p:sp>
         <p:nvSpPr>
@@ -12898,6 +13411,13 @@
             <a:prstDash val="solid"/>
           </a:ln>
         </p:spPr>
+        <p:txBody>
+          <a:bodyPr/>
+          <a:lstStyle/>
+          <a:p>
+            <a:endParaRPr lang="en-IN"/>
+          </a:p>
+        </p:txBody>
       </p:sp>
       <p:sp>
         <p:nvSpPr>
@@ -12982,6 +13502,7 @@
             <a:pPr algn="l"/>
             <a:fld id="{F7021451-1387-4CA6-816F-3879F97B5CBC}" type="slidenum">
               <a:rPr lang="en-US" b="0"/>
+              <a:t>8</a:t>
             </a:fld>
             <a:endParaRPr lang="en-US"/>
           </a:p>
@@ -13544,9 +14065,27 @@
             <a:tbl>
               <a:tblPr/>
               <a:tblGrid>
-                <a:gridCol w="1188720"/>
-                <a:gridCol w="1554480"/>
-                <a:gridCol w="1280160"/>
+                <a:gridCol w="1188720">
+                  <a:extLst>
+                    <a:ext uri="{9D8B030D-6E8A-4147-A177-3AD203B41FA5}">
+                      <a16:colId xmlns:a16="http://schemas.microsoft.com/office/drawing/2014/main" val="20000"/>
+                    </a:ext>
+                  </a:extLst>
+                </a:gridCol>
+                <a:gridCol w="1554480">
+                  <a:extLst>
+                    <a:ext uri="{9D8B030D-6E8A-4147-A177-3AD203B41FA5}">
+                      <a16:colId xmlns:a16="http://schemas.microsoft.com/office/drawing/2014/main" val="20001"/>
+                    </a:ext>
+                  </a:extLst>
+                </a:gridCol>
+                <a:gridCol w="1280160">
+                  <a:extLst>
+                    <a:ext uri="{9D8B030D-6E8A-4147-A177-3AD203B41FA5}">
+                      <a16:colId xmlns:a16="http://schemas.microsoft.com/office/drawing/2014/main" val="20002"/>
+                    </a:ext>
+                  </a:extLst>
+                </a:gridCol>
               </a:tblGrid>
               <a:tr h="329184">
                 <a:tc>
@@ -13753,6 +14292,11 @@
                     </a:solidFill>
                   </a:tcPr>
                 </a:tc>
+                <a:extLst>
+                  <a:ext uri="{0D108BD9-81ED-4DB2-BD59-A6C34878D82A}">
+                    <a16:rowId xmlns:a16="http://schemas.microsoft.com/office/drawing/2014/main" val="10000"/>
+                  </a:ext>
+                </a:extLst>
               </a:tr>
               <a:tr h="329184">
                 <a:tc>
@@ -13959,6 +14503,11 @@
                     </a:solidFill>
                   </a:tcPr>
                 </a:tc>
+                <a:extLst>
+                  <a:ext uri="{0D108BD9-81ED-4DB2-BD59-A6C34878D82A}">
+                    <a16:rowId xmlns:a16="http://schemas.microsoft.com/office/drawing/2014/main" val="10001"/>
+                  </a:ext>
+                </a:extLst>
               </a:tr>
               <a:tr h="329184">
                 <a:tc>
@@ -14165,6 +14714,11 @@
                     </a:solidFill>
                   </a:tcPr>
                 </a:tc>
+                <a:extLst>
+                  <a:ext uri="{0D108BD9-81ED-4DB2-BD59-A6C34878D82A}">
+                    <a16:rowId xmlns:a16="http://schemas.microsoft.com/office/drawing/2014/main" val="10002"/>
+                  </a:ext>
+                </a:extLst>
               </a:tr>
               <a:tr h="329184">
                 <a:tc>
@@ -14371,6 +14925,11 @@
                     </a:solidFill>
                   </a:tcPr>
                 </a:tc>
+                <a:extLst>
+                  <a:ext uri="{0D108BD9-81ED-4DB2-BD59-A6C34878D82A}">
+                    <a16:rowId xmlns:a16="http://schemas.microsoft.com/office/drawing/2014/main" val="10003"/>
+                  </a:ext>
+                </a:extLst>
               </a:tr>
               <a:tr h="329184">
                 <a:tc>
@@ -14577,6 +15136,11 @@
                     </a:solidFill>
                   </a:tcPr>
                 </a:tc>
+                <a:extLst>
+                  <a:ext uri="{0D108BD9-81ED-4DB2-BD59-A6C34878D82A}">
+                    <a16:rowId xmlns:a16="http://schemas.microsoft.com/office/drawing/2014/main" val="10004"/>
+                  </a:ext>
+                </a:extLst>
               </a:tr>
               <a:tr h="329184">
                 <a:tc>
@@ -14783,6 +15347,11 @@
                     </a:solidFill>
                   </a:tcPr>
                 </a:tc>
+                <a:extLst>
+                  <a:ext uri="{0D108BD9-81ED-4DB2-BD59-A6C34878D82A}">
+                    <a16:rowId xmlns:a16="http://schemas.microsoft.com/office/drawing/2014/main" val="10005"/>
+                  </a:ext>
+                </a:extLst>
               </a:tr>
               <a:tr h="329184">
                 <a:tc>
@@ -14989,6 +15558,11 @@
                     </a:solidFill>
                   </a:tcPr>
                 </a:tc>
+                <a:extLst>
+                  <a:ext uri="{0D108BD9-81ED-4DB2-BD59-A6C34878D82A}">
+                    <a16:rowId xmlns:a16="http://schemas.microsoft.com/office/drawing/2014/main" val="10006"/>
+                  </a:ext>
+                </a:extLst>
               </a:tr>
               <a:tr h="329184">
                 <a:tc>
@@ -15195,6 +15769,11 @@
                     </a:solidFill>
                   </a:tcPr>
                 </a:tc>
+                <a:extLst>
+                  <a:ext uri="{0D108BD9-81ED-4DB2-BD59-A6C34878D82A}">
+                    <a16:rowId xmlns:a16="http://schemas.microsoft.com/office/drawing/2014/main" val="10007"/>
+                  </a:ext>
+                </a:extLst>
               </a:tr>
               <a:tr h="329184">
                 <a:tc>
@@ -15401,6 +15980,11 @@
                     </a:solidFill>
                   </a:tcPr>
                 </a:tc>
+                <a:extLst>
+                  <a:ext uri="{0D108BD9-81ED-4DB2-BD59-A6C34878D82A}">
+                    <a16:rowId xmlns:a16="http://schemas.microsoft.com/office/drawing/2014/main" val="10008"/>
+                  </a:ext>
+                </a:extLst>
               </a:tr>
               <a:tr h="329184">
                 <a:tc>
@@ -15607,6 +16191,11 @@
                     </a:solidFill>
                   </a:tcPr>
                 </a:tc>
+                <a:extLst>
+                  <a:ext uri="{0D108BD9-81ED-4DB2-BD59-A6C34878D82A}">
+                    <a16:rowId xmlns:a16="http://schemas.microsoft.com/office/drawing/2014/main" val="10009"/>
+                  </a:ext>
+                </a:extLst>
               </a:tr>
             </a:tbl>
           </a:graphicData>
@@ -15645,6 +16234,13 @@
             </a:outerShdw>
           </a:effectLst>
         </p:spPr>
+        <p:txBody>
+          <a:bodyPr/>
+          <a:lstStyle/>
+          <a:p>
+            <a:endParaRPr lang="en-IN"/>
+          </a:p>
+        </p:txBody>
       </p:sp>
       <p:sp>
         <p:nvSpPr>
@@ -15755,6 +16351,13 @@
             </a:outerShdw>
           </a:effectLst>
         </p:spPr>
+        <p:txBody>
+          <a:bodyPr/>
+          <a:lstStyle/>
+          <a:p>
+            <a:endParaRPr lang="en-IN"/>
+          </a:p>
+        </p:txBody>
       </p:sp>
       <p:sp>
         <p:nvSpPr>
@@ -15865,6 +16468,13 @@
             </a:outerShdw>
           </a:effectLst>
         </p:spPr>
+        <p:txBody>
+          <a:bodyPr/>
+          <a:lstStyle/>
+          <a:p>
+            <a:endParaRPr lang="en-IN"/>
+          </a:p>
+        </p:txBody>
       </p:sp>
       <p:sp>
         <p:nvSpPr>
@@ -15976,6 +16586,7 @@
             <a:pPr algn="l"/>
             <a:fld id="{F7021451-1387-4CA6-816F-3879F97B5CBC}" type="slidenum">
               <a:rPr lang="en-US" b="0"/>
+              <a:t>9</a:t>
             </a:fld>
             <a:endParaRPr lang="en-US"/>
           </a:p>
@@ -16695,6 +17306,8 @@
       </a:bgFillStyleLst>
     </a:fmtScheme>
   </a:themeElements>
+  <a:objectDefaults/>
+  <a:extraClrSchemeLst/>
   <a:extLst>
     <a:ext uri="{05A4C25C-085E-4340-85A3-A5531E510DB2}">
       <thm15:themeFamily xmlns:thm15="http://schemas.microsoft.com/office/thememl/2012/main" name="Office Theme" id="{62F939B6-93AF-4DB8-9C6B-D6C7DFDC589F}" vid="{4A3C46E8-61CC-4603-A589-7422A47A8E4A}"/>
@@ -16975,6 +17588,7 @@
       </a:style>
     </a:lnDef>
   </a:objectDefaults>
+  <a:extraClrSchemeLst/>
   <a:extLst>
     <a:ext uri="{05A4C25C-085E-4340-85A3-A5531E510DB2}">
       <thm15:themeFamily xmlns:thm15="http://schemas.microsoft.com/office/thememl/2012/main" name="Office Theme" id="{62F939B6-93AF-4DB8-9C6B-D6C7DFDC589F}" vid="{4A3C46E8-61CC-4603-A589-7422A47A8E4A}"/>

</xml_diff>